<commit_message>
Corrected rendering of 04/Generalization
</commit_message>
<xml_diff>
--- a/figs/DIYfigures_icpa1.pptx
+++ b/figs/DIYfigures_icpa1.pptx
@@ -6,6 +6,8 @@
   </p:sldMasterIdLst>
   <p:sldIdLst>
     <p:sldId id="256" r:id="rId2"/>
+    <p:sldId id="257" r:id="rId3"/>
+    <p:sldId id="258" r:id="rId4"/>
   </p:sldIdLst>
   <p:sldSz cx="12192000" cy="6858000"/>
   <p:notesSz cx="6858000" cy="9144000"/>
@@ -259,7 +261,7 @@
           <a:p>
             <a:fld id="{F4B6AA23-F6BB-FA47-96B5-569FAB187581}" type="datetimeFigureOut">
               <a:rPr kumimoji="1" lang="ja-JP" altLang="en-US" smtClean="0"/>
-              <a:t>2026/4/24</a:t>
+              <a:t>2026/5/19</a:t>
             </a:fld>
             <a:endParaRPr kumimoji="1" lang="ja-JP" altLang="en-US"/>
           </a:p>
@@ -489,7 +491,7 @@
           <a:p>
             <a:fld id="{F4B6AA23-F6BB-FA47-96B5-569FAB187581}" type="datetimeFigureOut">
               <a:rPr kumimoji="1" lang="ja-JP" altLang="en-US" smtClean="0"/>
-              <a:t>2026/4/24</a:t>
+              <a:t>2026/5/19</a:t>
             </a:fld>
             <a:endParaRPr kumimoji="1" lang="ja-JP" altLang="en-US"/>
           </a:p>
@@ -729,7 +731,7 @@
           <a:p>
             <a:fld id="{F4B6AA23-F6BB-FA47-96B5-569FAB187581}" type="datetimeFigureOut">
               <a:rPr kumimoji="1" lang="ja-JP" altLang="en-US" smtClean="0"/>
-              <a:t>2026/4/24</a:t>
+              <a:t>2026/5/19</a:t>
             </a:fld>
             <a:endParaRPr kumimoji="1" lang="ja-JP" altLang="en-US"/>
           </a:p>
@@ -959,7 +961,7 @@
           <a:p>
             <a:fld id="{F4B6AA23-F6BB-FA47-96B5-569FAB187581}" type="datetimeFigureOut">
               <a:rPr kumimoji="1" lang="ja-JP" altLang="en-US" smtClean="0"/>
-              <a:t>2026/4/24</a:t>
+              <a:t>2026/5/19</a:t>
             </a:fld>
             <a:endParaRPr kumimoji="1" lang="ja-JP" altLang="en-US"/>
           </a:p>
@@ -1234,7 +1236,7 @@
           <a:p>
             <a:fld id="{F4B6AA23-F6BB-FA47-96B5-569FAB187581}" type="datetimeFigureOut">
               <a:rPr kumimoji="1" lang="ja-JP" altLang="en-US" smtClean="0"/>
-              <a:t>2026/4/24</a:t>
+              <a:t>2026/5/19</a:t>
             </a:fld>
             <a:endParaRPr kumimoji="1" lang="ja-JP" altLang="en-US"/>
           </a:p>
@@ -1563,7 +1565,7 @@
           <a:p>
             <a:fld id="{F4B6AA23-F6BB-FA47-96B5-569FAB187581}" type="datetimeFigureOut">
               <a:rPr kumimoji="1" lang="ja-JP" altLang="en-US" smtClean="0"/>
-              <a:t>2026/4/24</a:t>
+              <a:t>2026/5/19</a:t>
             </a:fld>
             <a:endParaRPr kumimoji="1" lang="ja-JP" altLang="en-US"/>
           </a:p>
@@ -2039,7 +2041,7 @@
           <a:p>
             <a:fld id="{F4B6AA23-F6BB-FA47-96B5-569FAB187581}" type="datetimeFigureOut">
               <a:rPr kumimoji="1" lang="ja-JP" altLang="en-US" smtClean="0"/>
-              <a:t>2026/4/24</a:t>
+              <a:t>2026/5/19</a:t>
             </a:fld>
             <a:endParaRPr kumimoji="1" lang="ja-JP" altLang="en-US"/>
           </a:p>
@@ -2180,7 +2182,7 @@
           <a:p>
             <a:fld id="{F4B6AA23-F6BB-FA47-96B5-569FAB187581}" type="datetimeFigureOut">
               <a:rPr kumimoji="1" lang="ja-JP" altLang="en-US" smtClean="0"/>
-              <a:t>2026/4/24</a:t>
+              <a:t>2026/5/19</a:t>
             </a:fld>
             <a:endParaRPr kumimoji="1" lang="ja-JP" altLang="en-US"/>
           </a:p>
@@ -2293,7 +2295,7 @@
           <a:p>
             <a:fld id="{F4B6AA23-F6BB-FA47-96B5-569FAB187581}" type="datetimeFigureOut">
               <a:rPr kumimoji="1" lang="ja-JP" altLang="en-US" smtClean="0"/>
-              <a:t>2026/4/24</a:t>
+              <a:t>2026/5/19</a:t>
             </a:fld>
             <a:endParaRPr kumimoji="1" lang="ja-JP" altLang="en-US"/>
           </a:p>
@@ -2636,7 +2638,7 @@
           <a:p>
             <a:fld id="{F4B6AA23-F6BB-FA47-96B5-569FAB187581}" type="datetimeFigureOut">
               <a:rPr kumimoji="1" lang="ja-JP" altLang="en-US" smtClean="0"/>
-              <a:t>2026/4/24</a:t>
+              <a:t>2026/5/19</a:t>
             </a:fld>
             <a:endParaRPr kumimoji="1" lang="ja-JP" altLang="en-US"/>
           </a:p>
@@ -2924,7 +2926,7 @@
           <a:p>
             <a:fld id="{F4B6AA23-F6BB-FA47-96B5-569FAB187581}" type="datetimeFigureOut">
               <a:rPr kumimoji="1" lang="ja-JP" altLang="en-US" smtClean="0"/>
-              <a:t>2026/4/24</a:t>
+              <a:t>2026/5/19</a:t>
             </a:fld>
             <a:endParaRPr kumimoji="1" lang="ja-JP" altLang="en-US"/>
           </a:p>
@@ -3197,7 +3199,7 @@
           <a:p>
             <a:fld id="{F4B6AA23-F6BB-FA47-96B5-569FAB187581}" type="datetimeFigureOut">
               <a:rPr kumimoji="1" lang="ja-JP" altLang="en-US" smtClean="0"/>
-              <a:t>2026/4/24</a:t>
+              <a:t>2026/5/19</a:t>
             </a:fld>
             <a:endParaRPr kumimoji="1" lang="ja-JP" altLang="en-US"/>
           </a:p>
@@ -5804,6 +5806,2084 @@
 </p:sld>
 </file>
 
+<file path=ppt/slides/slide2.xml><?xml version="1.0" encoding="utf-8"?>
+<p:sld xmlns:a="http://schemas.openxmlformats.org/drawingml/2006/main" xmlns:r="http://schemas.openxmlformats.org/officeDocument/2006/relationships" xmlns:p="http://schemas.openxmlformats.org/presentationml/2006/main">
+  <p:cSld>
+    <p:spTree>
+      <p:nvGrpSpPr>
+        <p:cNvPr id="1" name=""/>
+        <p:cNvGrpSpPr/>
+        <p:nvPr/>
+      </p:nvGrpSpPr>
+      <p:grpSpPr>
+        <a:xfrm>
+          <a:off x="0" y="0"/>
+          <a:ext cx="0" cy="0"/>
+          <a:chOff x="0" y="0"/>
+          <a:chExt cx="0" cy="0"/>
+        </a:xfrm>
+      </p:grpSpPr>
+      <p:grpSp>
+        <p:nvGrpSpPr>
+          <p:cNvPr id="12" name="グループ化 11">
+            <a:extLst>
+              <a:ext uri="{FF2B5EF4-FFF2-40B4-BE49-F238E27FC236}">
+                <a16:creationId xmlns:a16="http://schemas.microsoft.com/office/drawing/2014/main" id="{ACB17414-FA56-550A-21D8-6B4B3FC4C8C1}"/>
+              </a:ext>
+            </a:extLst>
+          </p:cNvPr>
+          <p:cNvGrpSpPr/>
+          <p:nvPr/>
+        </p:nvGrpSpPr>
+        <p:grpSpPr>
+          <a:xfrm>
+            <a:off x="1348450" y="850819"/>
+            <a:ext cx="9495100" cy="5156362"/>
+            <a:chOff x="2482298" y="1076272"/>
+            <a:chExt cx="7308088" cy="3968694"/>
+          </a:xfrm>
+        </p:grpSpPr>
+        <p:sp>
+          <p:nvSpPr>
+            <p:cNvPr id="6" name="右矢印 5">
+              <a:extLst>
+                <a:ext uri="{FF2B5EF4-FFF2-40B4-BE49-F238E27FC236}">
+                  <a16:creationId xmlns:a16="http://schemas.microsoft.com/office/drawing/2014/main" id="{BD264895-928B-FAB8-90F4-5CAEF8A93842}"/>
+                </a:ext>
+              </a:extLst>
+            </p:cNvPr>
+            <p:cNvSpPr/>
+            <p:nvPr/>
+          </p:nvSpPr>
+          <p:spPr>
+            <a:xfrm>
+              <a:off x="5160577" y="4277191"/>
+              <a:ext cx="2060029" cy="536028"/>
+            </a:xfrm>
+            <a:prstGeom prst="rightArrow">
+              <a:avLst/>
+            </a:prstGeom>
+            <a:solidFill>
+              <a:schemeClr val="bg1"/>
+            </a:solidFill>
+            <a:ln w="38100"/>
+          </p:spPr>
+          <p:style>
+            <a:lnRef idx="2">
+              <a:schemeClr val="accent1">
+                <a:shade val="15000"/>
+              </a:schemeClr>
+            </a:lnRef>
+            <a:fillRef idx="1">
+              <a:schemeClr val="accent1"/>
+            </a:fillRef>
+            <a:effectRef idx="0">
+              <a:schemeClr val="accent1"/>
+            </a:effectRef>
+            <a:fontRef idx="minor">
+              <a:schemeClr val="lt1"/>
+            </a:fontRef>
+          </p:style>
+          <p:txBody>
+            <a:bodyPr rtlCol="0" anchor="ctr"/>
+            <a:lstStyle/>
+            <a:p>
+              <a:pPr algn="ctr"/>
+              <a:endParaRPr kumimoji="1" lang="ja-JP" altLang="en-US"/>
+            </a:p>
+          </p:txBody>
+        </p:sp>
+        <p:cxnSp>
+          <p:nvCxnSpPr>
+            <p:cNvPr id="8" name="直線矢印コネクタ 7">
+              <a:extLst>
+                <a:ext uri="{FF2B5EF4-FFF2-40B4-BE49-F238E27FC236}">
+                  <a16:creationId xmlns:a16="http://schemas.microsoft.com/office/drawing/2014/main" id="{515DFBD7-377E-B9B4-62A2-3360E77A5C75}"/>
+                </a:ext>
+              </a:extLst>
+            </p:cNvPr>
+            <p:cNvCxnSpPr>
+              <a:stCxn id="5" idx="2"/>
+              <a:endCxn id="2" idx="0"/>
+            </p:cNvCxnSpPr>
+            <p:nvPr/>
+          </p:nvCxnSpPr>
+          <p:spPr>
+            <a:xfrm flipH="1">
+              <a:off x="3690060" y="2075794"/>
+              <a:ext cx="2405940" cy="1969650"/>
+            </a:xfrm>
+            <a:prstGeom prst="straightConnector1">
+              <a:avLst/>
+            </a:prstGeom>
+            <a:ln w="76200">
+              <a:solidFill>
+                <a:schemeClr val="tx1"/>
+              </a:solidFill>
+              <a:tailEnd type="triangle"/>
+            </a:ln>
+          </p:spPr>
+          <p:style>
+            <a:lnRef idx="2">
+              <a:schemeClr val="accent1"/>
+            </a:lnRef>
+            <a:fillRef idx="0">
+              <a:schemeClr val="accent1"/>
+            </a:fillRef>
+            <a:effectRef idx="1">
+              <a:schemeClr val="accent1"/>
+            </a:effectRef>
+            <a:fontRef idx="minor">
+              <a:schemeClr val="tx1"/>
+            </a:fontRef>
+          </p:style>
+        </p:cxnSp>
+        <p:cxnSp>
+          <p:nvCxnSpPr>
+            <p:cNvPr id="9" name="直線矢印コネクタ 8">
+              <a:extLst>
+                <a:ext uri="{FF2B5EF4-FFF2-40B4-BE49-F238E27FC236}">
+                  <a16:creationId xmlns:a16="http://schemas.microsoft.com/office/drawing/2014/main" id="{D454F49B-CC7A-7349-CA32-D1C576DDD224}"/>
+                </a:ext>
+              </a:extLst>
+            </p:cNvPr>
+            <p:cNvCxnSpPr>
+              <a:cxnSpLocks/>
+              <a:stCxn id="5" idx="2"/>
+              <a:endCxn id="4" idx="0"/>
+            </p:cNvCxnSpPr>
+            <p:nvPr/>
+          </p:nvCxnSpPr>
+          <p:spPr>
+            <a:xfrm>
+              <a:off x="6096000" y="2075794"/>
+              <a:ext cx="2486625" cy="1969650"/>
+            </a:xfrm>
+            <a:prstGeom prst="straightConnector1">
+              <a:avLst/>
+            </a:prstGeom>
+            <a:ln w="76200">
+              <a:solidFill>
+                <a:schemeClr val="tx1"/>
+              </a:solidFill>
+              <a:tailEnd type="triangle"/>
+            </a:ln>
+          </p:spPr>
+          <p:style>
+            <a:lnRef idx="2">
+              <a:schemeClr val="accent1"/>
+            </a:lnRef>
+            <a:fillRef idx="0">
+              <a:schemeClr val="accent1"/>
+            </a:fillRef>
+            <a:effectRef idx="1">
+              <a:schemeClr val="accent1"/>
+            </a:effectRef>
+            <a:fontRef idx="minor">
+              <a:schemeClr val="tx1"/>
+            </a:fontRef>
+          </p:style>
+        </p:cxnSp>
+        <p:sp>
+          <p:nvSpPr>
+            <p:cNvPr id="2" name="角丸四角形 1">
+              <a:extLst>
+                <a:ext uri="{FF2B5EF4-FFF2-40B4-BE49-F238E27FC236}">
+                  <a16:creationId xmlns:a16="http://schemas.microsoft.com/office/drawing/2014/main" id="{DE82100C-667F-71FB-99B6-44B7EFBF5940}"/>
+                </a:ext>
+              </a:extLst>
+            </p:cNvPr>
+            <p:cNvSpPr/>
+            <p:nvPr/>
+          </p:nvSpPr>
+          <p:spPr>
+            <a:xfrm>
+              <a:off x="2482298" y="4045444"/>
+              <a:ext cx="2415523" cy="999522"/>
+            </a:xfrm>
+            <a:prstGeom prst="roundRect">
+              <a:avLst/>
+            </a:prstGeom>
+            <a:solidFill>
+              <a:schemeClr val="bg1"/>
+            </a:solidFill>
+            <a:ln w="12700"/>
+          </p:spPr>
+          <p:style>
+            <a:lnRef idx="2">
+              <a:schemeClr val="accent1">
+                <a:shade val="15000"/>
+              </a:schemeClr>
+            </a:lnRef>
+            <a:fillRef idx="1">
+              <a:schemeClr val="accent1"/>
+            </a:fillRef>
+            <a:effectRef idx="0">
+              <a:schemeClr val="accent1"/>
+            </a:effectRef>
+            <a:fontRef idx="minor">
+              <a:schemeClr val="lt1"/>
+            </a:fontRef>
+          </p:style>
+          <p:txBody>
+            <a:bodyPr rtlCol="0" anchor="ctr"/>
+            <a:lstStyle/>
+            <a:p>
+              <a:pPr algn="ctr"/>
+              <a:r>
+                <a:rPr kumimoji="1" lang="ja-JP" altLang="en-US" sz="3200">
+                  <a:solidFill>
+                    <a:schemeClr val="tx1"/>
+                  </a:solidFill>
+                  <a:latin typeface="HGPSoeiKakugothicUB" panose="020B0900000000000000" pitchFamily="34" charset="-128"/>
+                  <a:ea typeface="HGPSoeiKakugothicUB" panose="020B0900000000000000" pitchFamily="34" charset="-128"/>
+                </a:rPr>
+                <a:t>独立変数</a:t>
+              </a:r>
+            </a:p>
+          </p:txBody>
+        </p:sp>
+        <p:sp>
+          <p:nvSpPr>
+            <p:cNvPr id="4" name="角丸四角形 3">
+              <a:extLst>
+                <a:ext uri="{FF2B5EF4-FFF2-40B4-BE49-F238E27FC236}">
+                  <a16:creationId xmlns:a16="http://schemas.microsoft.com/office/drawing/2014/main" id="{8BAEACF2-460E-6BA4-7784-008AE9744D22}"/>
+                </a:ext>
+              </a:extLst>
+            </p:cNvPr>
+            <p:cNvSpPr/>
+            <p:nvPr/>
+          </p:nvSpPr>
+          <p:spPr>
+            <a:xfrm>
+              <a:off x="7374863" y="4045444"/>
+              <a:ext cx="2415523" cy="999522"/>
+            </a:xfrm>
+            <a:prstGeom prst="roundRect">
+              <a:avLst/>
+            </a:prstGeom>
+            <a:solidFill>
+              <a:schemeClr val="bg1"/>
+            </a:solidFill>
+            <a:ln w="12700"/>
+          </p:spPr>
+          <p:style>
+            <a:lnRef idx="2">
+              <a:schemeClr val="accent1">
+                <a:shade val="15000"/>
+              </a:schemeClr>
+            </a:lnRef>
+            <a:fillRef idx="1">
+              <a:schemeClr val="accent1"/>
+            </a:fillRef>
+            <a:effectRef idx="0">
+              <a:schemeClr val="accent1"/>
+            </a:effectRef>
+            <a:fontRef idx="minor">
+              <a:schemeClr val="lt1"/>
+            </a:fontRef>
+          </p:style>
+          <p:txBody>
+            <a:bodyPr rtlCol="0" anchor="ctr"/>
+            <a:lstStyle/>
+            <a:p>
+              <a:pPr algn="ctr"/>
+              <a:r>
+                <a:rPr lang="ja-JP" altLang="en-US" sz="3200">
+                  <a:solidFill>
+                    <a:schemeClr val="tx1"/>
+                  </a:solidFill>
+                  <a:latin typeface="HGPSoeiKakugothicUB" panose="020B0900000000000000" pitchFamily="34" charset="-128"/>
+                  <a:ea typeface="HGPSoeiKakugothicUB" panose="020B0900000000000000" pitchFamily="34" charset="-128"/>
+                </a:rPr>
+                <a:t>従属</a:t>
+              </a:r>
+              <a:r>
+                <a:rPr kumimoji="1" lang="ja-JP" altLang="en-US" sz="3200">
+                  <a:solidFill>
+                    <a:schemeClr val="tx1"/>
+                  </a:solidFill>
+                  <a:latin typeface="HGPSoeiKakugothicUB" panose="020B0900000000000000" pitchFamily="34" charset="-128"/>
+                  <a:ea typeface="HGPSoeiKakugothicUB" panose="020B0900000000000000" pitchFamily="34" charset="-128"/>
+                </a:rPr>
+                <a:t>変数</a:t>
+              </a:r>
+            </a:p>
+          </p:txBody>
+        </p:sp>
+        <p:sp>
+          <p:nvSpPr>
+            <p:cNvPr id="5" name="角丸四角形 4">
+              <a:extLst>
+                <a:ext uri="{FF2B5EF4-FFF2-40B4-BE49-F238E27FC236}">
+                  <a16:creationId xmlns:a16="http://schemas.microsoft.com/office/drawing/2014/main" id="{900D841B-5B46-4EB6-71DF-044CDCCBB3CA}"/>
+                </a:ext>
+              </a:extLst>
+            </p:cNvPr>
+            <p:cNvSpPr/>
+            <p:nvPr/>
+          </p:nvSpPr>
+          <p:spPr>
+            <a:xfrm>
+              <a:off x="4888238" y="1076272"/>
+              <a:ext cx="2415523" cy="999522"/>
+            </a:xfrm>
+            <a:prstGeom prst="roundRect">
+              <a:avLst/>
+            </a:prstGeom>
+            <a:solidFill>
+              <a:schemeClr val="bg1"/>
+            </a:solidFill>
+            <a:ln w="12700"/>
+          </p:spPr>
+          <p:style>
+            <a:lnRef idx="2">
+              <a:schemeClr val="accent1">
+                <a:shade val="15000"/>
+              </a:schemeClr>
+            </a:lnRef>
+            <a:fillRef idx="1">
+              <a:schemeClr val="accent1"/>
+            </a:fillRef>
+            <a:effectRef idx="0">
+              <a:schemeClr val="accent1"/>
+            </a:effectRef>
+            <a:fontRef idx="minor">
+              <a:schemeClr val="lt1"/>
+            </a:fontRef>
+          </p:style>
+          <p:txBody>
+            <a:bodyPr rtlCol="0" anchor="ctr"/>
+            <a:lstStyle/>
+            <a:p>
+              <a:pPr algn="ctr"/>
+              <a:r>
+                <a:rPr kumimoji="1" lang="ja-JP" altLang="en-US" sz="3200">
+                  <a:solidFill>
+                    <a:schemeClr val="tx1"/>
+                  </a:solidFill>
+                  <a:latin typeface="HGPSoeiKakugothicUB" panose="020B0900000000000000" pitchFamily="34" charset="-128"/>
+                  <a:ea typeface="HGPSoeiKakugothicUB" panose="020B0900000000000000" pitchFamily="34" charset="-128"/>
+                </a:rPr>
+                <a:t>交絡変数</a:t>
+              </a:r>
+            </a:p>
+          </p:txBody>
+        </p:sp>
+      </p:grpSp>
+    </p:spTree>
+    <p:extLst>
+      <p:ext uri="{BB962C8B-B14F-4D97-AF65-F5344CB8AC3E}">
+        <p14:creationId xmlns:p14="http://schemas.microsoft.com/office/powerpoint/2010/main" val="1338678905"/>
+      </p:ext>
+    </p:extLst>
+  </p:cSld>
+  <p:clrMapOvr>
+    <a:masterClrMapping/>
+  </p:clrMapOvr>
+</p:sld>
+</file>
+
+<file path=ppt/slides/slide3.xml><?xml version="1.0" encoding="utf-8"?>
+<p:sld xmlns:a="http://schemas.openxmlformats.org/drawingml/2006/main" xmlns:r="http://schemas.openxmlformats.org/officeDocument/2006/relationships" xmlns:p="http://schemas.openxmlformats.org/presentationml/2006/main">
+  <p:cSld>
+    <p:spTree>
+      <p:nvGrpSpPr>
+        <p:cNvPr id="1" name=""/>
+        <p:cNvGrpSpPr/>
+        <p:nvPr/>
+      </p:nvGrpSpPr>
+      <p:grpSpPr>
+        <a:xfrm>
+          <a:off x="0" y="0"/>
+          <a:ext cx="0" cy="0"/>
+          <a:chOff x="0" y="0"/>
+          <a:chExt cx="0" cy="0"/>
+        </a:xfrm>
+      </p:grpSpPr>
+      <p:grpSp>
+        <p:nvGrpSpPr>
+          <p:cNvPr id="51" name="グループ化 50">
+            <a:extLst>
+              <a:ext uri="{FF2B5EF4-FFF2-40B4-BE49-F238E27FC236}">
+                <a16:creationId xmlns:a16="http://schemas.microsoft.com/office/drawing/2014/main" id="{414C7DFC-2067-E5B0-9EFA-E2C50FACD3A8}"/>
+              </a:ext>
+            </a:extLst>
+          </p:cNvPr>
+          <p:cNvGrpSpPr/>
+          <p:nvPr/>
+        </p:nvGrpSpPr>
+        <p:grpSpPr>
+          <a:xfrm>
+            <a:off x="1905727" y="601966"/>
+            <a:ext cx="7419862" cy="5189606"/>
+            <a:chOff x="1905727" y="601966"/>
+            <a:chExt cx="7419862" cy="5189606"/>
+          </a:xfrm>
+        </p:grpSpPr>
+        <p:cxnSp>
+          <p:nvCxnSpPr>
+            <p:cNvPr id="32" name="直線コネクタ 31">
+              <a:extLst>
+                <a:ext uri="{FF2B5EF4-FFF2-40B4-BE49-F238E27FC236}">
+                  <a16:creationId xmlns:a16="http://schemas.microsoft.com/office/drawing/2014/main" id="{29E2D657-3CA1-0A70-3A05-57192B54A3C8}"/>
+                </a:ext>
+              </a:extLst>
+            </p:cNvPr>
+            <p:cNvCxnSpPr/>
+            <p:nvPr/>
+          </p:nvCxnSpPr>
+          <p:spPr>
+            <a:xfrm flipV="1">
+              <a:off x="2866411" y="1491867"/>
+              <a:ext cx="4931923" cy="3600576"/>
+            </a:xfrm>
+            <a:prstGeom prst="line">
+              <a:avLst/>
+            </a:prstGeom>
+            <a:ln w="38100">
+              <a:solidFill>
+                <a:schemeClr val="tx1"/>
+              </a:solidFill>
+            </a:ln>
+          </p:spPr>
+          <p:style>
+            <a:lnRef idx="2">
+              <a:schemeClr val="accent1"/>
+            </a:lnRef>
+            <a:fillRef idx="0">
+              <a:schemeClr val="accent1"/>
+            </a:fillRef>
+            <a:effectRef idx="1">
+              <a:schemeClr val="accent1"/>
+            </a:effectRef>
+            <a:fontRef idx="minor">
+              <a:schemeClr val="tx1"/>
+            </a:fontRef>
+          </p:style>
+        </p:cxnSp>
+        <p:cxnSp>
+          <p:nvCxnSpPr>
+            <p:cNvPr id="2" name="直線矢印コネクタ 1">
+              <a:extLst>
+                <a:ext uri="{FF2B5EF4-FFF2-40B4-BE49-F238E27FC236}">
+                  <a16:creationId xmlns:a16="http://schemas.microsoft.com/office/drawing/2014/main" id="{E3CD74C2-29C8-555B-0198-7F4A42513ECD}"/>
+                </a:ext>
+              </a:extLst>
+            </p:cNvPr>
+            <p:cNvCxnSpPr>
+              <a:cxnSpLocks/>
+            </p:cNvCxnSpPr>
+            <p:nvPr/>
+          </p:nvCxnSpPr>
+          <p:spPr>
+            <a:xfrm>
+              <a:off x="2354318" y="5349674"/>
+              <a:ext cx="6846465" cy="0"/>
+            </a:xfrm>
+            <a:prstGeom prst="straightConnector1">
+              <a:avLst/>
+            </a:prstGeom>
+            <a:ln w="38100">
+              <a:solidFill>
+                <a:schemeClr val="tx1"/>
+              </a:solidFill>
+              <a:tailEnd type="triangle"/>
+            </a:ln>
+          </p:spPr>
+          <p:style>
+            <a:lnRef idx="2">
+              <a:schemeClr val="accent1"/>
+            </a:lnRef>
+            <a:fillRef idx="0">
+              <a:schemeClr val="accent1"/>
+            </a:fillRef>
+            <a:effectRef idx="1">
+              <a:schemeClr val="accent1"/>
+            </a:effectRef>
+            <a:fontRef idx="minor">
+              <a:schemeClr val="tx1"/>
+            </a:fontRef>
+          </p:style>
+        </p:cxnSp>
+        <p:cxnSp>
+          <p:nvCxnSpPr>
+            <p:cNvPr id="4" name="直線矢印コネクタ 3">
+              <a:extLst>
+                <a:ext uri="{FF2B5EF4-FFF2-40B4-BE49-F238E27FC236}">
+                  <a16:creationId xmlns:a16="http://schemas.microsoft.com/office/drawing/2014/main" id="{B4466AA5-A4B3-7B1D-5CB4-728C02DBA3E4}"/>
+                </a:ext>
+              </a:extLst>
+            </p:cNvPr>
+            <p:cNvCxnSpPr>
+              <a:cxnSpLocks/>
+            </p:cNvCxnSpPr>
+            <p:nvPr/>
+          </p:nvCxnSpPr>
+          <p:spPr>
+            <a:xfrm flipV="1">
+              <a:off x="2349064" y="677917"/>
+              <a:ext cx="0" cy="4671757"/>
+            </a:xfrm>
+            <a:prstGeom prst="straightConnector1">
+              <a:avLst/>
+            </a:prstGeom>
+            <a:ln w="38100">
+              <a:solidFill>
+                <a:schemeClr val="tx1"/>
+              </a:solidFill>
+              <a:tailEnd type="triangle"/>
+            </a:ln>
+          </p:spPr>
+          <p:style>
+            <a:lnRef idx="2">
+              <a:schemeClr val="accent1"/>
+            </a:lnRef>
+            <a:fillRef idx="0">
+              <a:schemeClr val="accent1"/>
+            </a:fillRef>
+            <a:effectRef idx="1">
+              <a:schemeClr val="accent1"/>
+            </a:effectRef>
+            <a:fontRef idx="minor">
+              <a:schemeClr val="tx1"/>
+            </a:fontRef>
+          </p:style>
+        </p:cxnSp>
+        <p:sp>
+          <p:nvSpPr>
+            <p:cNvPr id="7" name="円/楕円 6">
+              <a:extLst>
+                <a:ext uri="{FF2B5EF4-FFF2-40B4-BE49-F238E27FC236}">
+                  <a16:creationId xmlns:a16="http://schemas.microsoft.com/office/drawing/2014/main" id="{A7C999FA-2938-11EF-5D1C-8668E86C0309}"/>
+                </a:ext>
+              </a:extLst>
+            </p:cNvPr>
+            <p:cNvSpPr/>
+            <p:nvPr/>
+          </p:nvSpPr>
+          <p:spPr>
+            <a:xfrm>
+              <a:off x="5150069" y="2785969"/>
+              <a:ext cx="97977" cy="97975"/>
+            </a:xfrm>
+            <a:prstGeom prst="ellipse">
+              <a:avLst/>
+            </a:prstGeom>
+            <a:solidFill>
+              <a:srgbClr val="00B0F0"/>
+            </a:solidFill>
+            <a:ln>
+              <a:noFill/>
+            </a:ln>
+          </p:spPr>
+          <p:style>
+            <a:lnRef idx="2">
+              <a:schemeClr val="accent1">
+                <a:shade val="15000"/>
+              </a:schemeClr>
+            </a:lnRef>
+            <a:fillRef idx="1">
+              <a:schemeClr val="accent1"/>
+            </a:fillRef>
+            <a:effectRef idx="0">
+              <a:schemeClr val="accent1"/>
+            </a:effectRef>
+            <a:fontRef idx="minor">
+              <a:schemeClr val="lt1"/>
+            </a:fontRef>
+          </p:style>
+          <p:txBody>
+            <a:bodyPr rtlCol="0" anchor="ctr"/>
+            <a:lstStyle/>
+            <a:p>
+              <a:pPr algn="ctr"/>
+              <a:endParaRPr kumimoji="1" lang="ja-JP" altLang="en-US"/>
+            </a:p>
+          </p:txBody>
+        </p:sp>
+        <p:sp>
+          <p:nvSpPr>
+            <p:cNvPr id="8" name="円/楕円 7">
+              <a:extLst>
+                <a:ext uri="{FF2B5EF4-FFF2-40B4-BE49-F238E27FC236}">
+                  <a16:creationId xmlns:a16="http://schemas.microsoft.com/office/drawing/2014/main" id="{F4EF0EA4-D3C5-762C-8CA8-BDCB52E3FA3E}"/>
+                </a:ext>
+              </a:extLst>
+            </p:cNvPr>
+            <p:cNvSpPr/>
+            <p:nvPr/>
+          </p:nvSpPr>
+          <p:spPr>
+            <a:xfrm>
+              <a:off x="4708500" y="3194181"/>
+              <a:ext cx="97977" cy="97975"/>
+            </a:xfrm>
+            <a:prstGeom prst="ellipse">
+              <a:avLst/>
+            </a:prstGeom>
+            <a:solidFill>
+              <a:srgbClr val="00B0F0"/>
+            </a:solidFill>
+            <a:ln>
+              <a:noFill/>
+            </a:ln>
+          </p:spPr>
+          <p:style>
+            <a:lnRef idx="2">
+              <a:schemeClr val="accent1">
+                <a:shade val="15000"/>
+              </a:schemeClr>
+            </a:lnRef>
+            <a:fillRef idx="1">
+              <a:schemeClr val="accent1"/>
+            </a:fillRef>
+            <a:effectRef idx="0">
+              <a:schemeClr val="accent1"/>
+            </a:effectRef>
+            <a:fontRef idx="minor">
+              <a:schemeClr val="lt1"/>
+            </a:fontRef>
+          </p:style>
+          <p:txBody>
+            <a:bodyPr rtlCol="0" anchor="ctr"/>
+            <a:lstStyle/>
+            <a:p>
+              <a:pPr algn="ctr"/>
+              <a:endParaRPr kumimoji="1" lang="ja-JP" altLang="en-US"/>
+            </a:p>
+          </p:txBody>
+        </p:sp>
+        <p:sp>
+          <p:nvSpPr>
+            <p:cNvPr id="9" name="円/楕円 8">
+              <a:extLst>
+                <a:ext uri="{FF2B5EF4-FFF2-40B4-BE49-F238E27FC236}">
+                  <a16:creationId xmlns:a16="http://schemas.microsoft.com/office/drawing/2014/main" id="{859CF216-D83E-B623-B3BF-357A3E8B9FA9}"/>
+                </a:ext>
+              </a:extLst>
+            </p:cNvPr>
+            <p:cNvSpPr/>
+            <p:nvPr/>
+          </p:nvSpPr>
+          <p:spPr>
+            <a:xfrm>
+              <a:off x="4438869" y="3880880"/>
+              <a:ext cx="97977" cy="97975"/>
+            </a:xfrm>
+            <a:prstGeom prst="ellipse">
+              <a:avLst/>
+            </a:prstGeom>
+            <a:solidFill>
+              <a:srgbClr val="00B0F0"/>
+            </a:solidFill>
+            <a:ln>
+              <a:noFill/>
+            </a:ln>
+          </p:spPr>
+          <p:style>
+            <a:lnRef idx="2">
+              <a:schemeClr val="accent1">
+                <a:shade val="15000"/>
+              </a:schemeClr>
+            </a:lnRef>
+            <a:fillRef idx="1">
+              <a:schemeClr val="accent1"/>
+            </a:fillRef>
+            <a:effectRef idx="0">
+              <a:schemeClr val="accent1"/>
+            </a:effectRef>
+            <a:fontRef idx="minor">
+              <a:schemeClr val="lt1"/>
+            </a:fontRef>
+          </p:style>
+          <p:txBody>
+            <a:bodyPr rtlCol="0" anchor="ctr"/>
+            <a:lstStyle/>
+            <a:p>
+              <a:pPr algn="ctr"/>
+              <a:endParaRPr kumimoji="1" lang="ja-JP" altLang="en-US"/>
+            </a:p>
+          </p:txBody>
+        </p:sp>
+        <p:sp>
+          <p:nvSpPr>
+            <p:cNvPr id="10" name="円/楕円 9">
+              <a:extLst>
+                <a:ext uri="{FF2B5EF4-FFF2-40B4-BE49-F238E27FC236}">
+                  <a16:creationId xmlns:a16="http://schemas.microsoft.com/office/drawing/2014/main" id="{F233B2E6-6712-E44B-9909-AA76A3ABCFED}"/>
+                </a:ext>
+              </a:extLst>
+            </p:cNvPr>
+            <p:cNvSpPr/>
+            <p:nvPr/>
+          </p:nvSpPr>
+          <p:spPr>
+            <a:xfrm>
+              <a:off x="4729988" y="3498981"/>
+              <a:ext cx="97977" cy="97975"/>
+            </a:xfrm>
+            <a:prstGeom prst="ellipse">
+              <a:avLst/>
+            </a:prstGeom>
+            <a:solidFill>
+              <a:srgbClr val="00B0F0"/>
+            </a:solidFill>
+            <a:ln>
+              <a:noFill/>
+            </a:ln>
+          </p:spPr>
+          <p:style>
+            <a:lnRef idx="2">
+              <a:schemeClr val="accent1">
+                <a:shade val="15000"/>
+              </a:schemeClr>
+            </a:lnRef>
+            <a:fillRef idx="1">
+              <a:schemeClr val="accent1"/>
+            </a:fillRef>
+            <a:effectRef idx="0">
+              <a:schemeClr val="accent1"/>
+            </a:effectRef>
+            <a:fontRef idx="minor">
+              <a:schemeClr val="lt1"/>
+            </a:fontRef>
+          </p:style>
+          <p:txBody>
+            <a:bodyPr rtlCol="0" anchor="ctr"/>
+            <a:lstStyle/>
+            <a:p>
+              <a:pPr algn="ctr"/>
+              <a:endParaRPr kumimoji="1" lang="ja-JP" altLang="en-US"/>
+            </a:p>
+          </p:txBody>
+        </p:sp>
+        <p:sp>
+          <p:nvSpPr>
+            <p:cNvPr id="11" name="円/楕円 10">
+              <a:extLst>
+                <a:ext uri="{FF2B5EF4-FFF2-40B4-BE49-F238E27FC236}">
+                  <a16:creationId xmlns:a16="http://schemas.microsoft.com/office/drawing/2014/main" id="{828E2A44-5152-CFAA-C1D6-489F2A40FF50}"/>
+                </a:ext>
+              </a:extLst>
+            </p:cNvPr>
+            <p:cNvSpPr/>
+            <p:nvPr/>
+          </p:nvSpPr>
+          <p:spPr>
+            <a:xfrm>
+              <a:off x="5853454" y="2947996"/>
+              <a:ext cx="97977" cy="97975"/>
+            </a:xfrm>
+            <a:prstGeom prst="ellipse">
+              <a:avLst/>
+            </a:prstGeom>
+            <a:solidFill>
+              <a:srgbClr val="00B0F0"/>
+            </a:solidFill>
+            <a:ln>
+              <a:noFill/>
+            </a:ln>
+          </p:spPr>
+          <p:style>
+            <a:lnRef idx="2">
+              <a:schemeClr val="accent1">
+                <a:shade val="15000"/>
+              </a:schemeClr>
+            </a:lnRef>
+            <a:fillRef idx="1">
+              <a:schemeClr val="accent1"/>
+            </a:fillRef>
+            <a:effectRef idx="0">
+              <a:schemeClr val="accent1"/>
+            </a:effectRef>
+            <a:fontRef idx="minor">
+              <a:schemeClr val="lt1"/>
+            </a:fontRef>
+          </p:style>
+          <p:txBody>
+            <a:bodyPr rtlCol="0" anchor="ctr"/>
+            <a:lstStyle/>
+            <a:p>
+              <a:pPr algn="ctr"/>
+              <a:endParaRPr kumimoji="1" lang="ja-JP" altLang="en-US"/>
+            </a:p>
+          </p:txBody>
+        </p:sp>
+        <p:sp>
+          <p:nvSpPr>
+            <p:cNvPr id="12" name="円/楕円 11">
+              <a:extLst>
+                <a:ext uri="{FF2B5EF4-FFF2-40B4-BE49-F238E27FC236}">
+                  <a16:creationId xmlns:a16="http://schemas.microsoft.com/office/drawing/2014/main" id="{42FB4E36-752F-E1DD-0B15-B4BB6F43B661}"/>
+                </a:ext>
+              </a:extLst>
+            </p:cNvPr>
+            <p:cNvSpPr/>
+            <p:nvPr/>
+          </p:nvSpPr>
+          <p:spPr>
+            <a:xfrm>
+              <a:off x="6263762" y="3243168"/>
+              <a:ext cx="97977" cy="97975"/>
+            </a:xfrm>
+            <a:prstGeom prst="ellipse">
+              <a:avLst/>
+            </a:prstGeom>
+            <a:solidFill>
+              <a:srgbClr val="00B0F0"/>
+            </a:solidFill>
+            <a:ln>
+              <a:noFill/>
+            </a:ln>
+          </p:spPr>
+          <p:style>
+            <a:lnRef idx="2">
+              <a:schemeClr val="accent1">
+                <a:shade val="15000"/>
+              </a:schemeClr>
+            </a:lnRef>
+            <a:fillRef idx="1">
+              <a:schemeClr val="accent1"/>
+            </a:fillRef>
+            <a:effectRef idx="0">
+              <a:schemeClr val="accent1"/>
+            </a:effectRef>
+            <a:fontRef idx="minor">
+              <a:schemeClr val="lt1"/>
+            </a:fontRef>
+          </p:style>
+          <p:txBody>
+            <a:bodyPr rtlCol="0" anchor="ctr"/>
+            <a:lstStyle/>
+            <a:p>
+              <a:pPr algn="ctr"/>
+              <a:endParaRPr kumimoji="1" lang="ja-JP" altLang="en-US"/>
+            </a:p>
+          </p:txBody>
+        </p:sp>
+        <p:sp>
+          <p:nvSpPr>
+            <p:cNvPr id="13" name="円/楕円 12">
+              <a:extLst>
+                <a:ext uri="{FF2B5EF4-FFF2-40B4-BE49-F238E27FC236}">
+                  <a16:creationId xmlns:a16="http://schemas.microsoft.com/office/drawing/2014/main" id="{ADFA7893-FF55-A677-5C4F-B350A5FAA381}"/>
+                </a:ext>
+              </a:extLst>
+            </p:cNvPr>
+            <p:cNvSpPr/>
+            <p:nvPr/>
+          </p:nvSpPr>
+          <p:spPr>
+            <a:xfrm>
+              <a:off x="5665768" y="2473384"/>
+              <a:ext cx="97977" cy="97975"/>
+            </a:xfrm>
+            <a:prstGeom prst="ellipse">
+              <a:avLst/>
+            </a:prstGeom>
+            <a:solidFill>
+              <a:srgbClr val="00B0F0"/>
+            </a:solidFill>
+            <a:ln>
+              <a:noFill/>
+            </a:ln>
+          </p:spPr>
+          <p:style>
+            <a:lnRef idx="2">
+              <a:schemeClr val="accent1">
+                <a:shade val="15000"/>
+              </a:schemeClr>
+            </a:lnRef>
+            <a:fillRef idx="1">
+              <a:schemeClr val="accent1"/>
+            </a:fillRef>
+            <a:effectRef idx="0">
+              <a:schemeClr val="accent1"/>
+            </a:effectRef>
+            <a:fontRef idx="minor">
+              <a:schemeClr val="lt1"/>
+            </a:fontRef>
+          </p:style>
+          <p:txBody>
+            <a:bodyPr rtlCol="0" anchor="ctr"/>
+            <a:lstStyle/>
+            <a:p>
+              <a:pPr algn="ctr"/>
+              <a:endParaRPr kumimoji="1" lang="ja-JP" altLang="en-US"/>
+            </a:p>
+          </p:txBody>
+        </p:sp>
+        <p:sp>
+          <p:nvSpPr>
+            <p:cNvPr id="14" name="円/楕円 13">
+              <a:extLst>
+                <a:ext uri="{FF2B5EF4-FFF2-40B4-BE49-F238E27FC236}">
+                  <a16:creationId xmlns:a16="http://schemas.microsoft.com/office/drawing/2014/main" id="{686D7146-DE45-6E10-0601-9973D943256E}"/>
+                </a:ext>
+              </a:extLst>
+            </p:cNvPr>
+            <p:cNvSpPr/>
+            <p:nvPr/>
+          </p:nvSpPr>
+          <p:spPr>
+            <a:xfrm>
+              <a:off x="5736209" y="3194180"/>
+              <a:ext cx="97977" cy="97975"/>
+            </a:xfrm>
+            <a:prstGeom prst="ellipse">
+              <a:avLst/>
+            </a:prstGeom>
+            <a:solidFill>
+              <a:srgbClr val="00B0F0"/>
+            </a:solidFill>
+            <a:ln>
+              <a:noFill/>
+            </a:ln>
+          </p:spPr>
+          <p:style>
+            <a:lnRef idx="2">
+              <a:schemeClr val="accent1">
+                <a:shade val="15000"/>
+              </a:schemeClr>
+            </a:lnRef>
+            <a:fillRef idx="1">
+              <a:schemeClr val="accent1"/>
+            </a:fillRef>
+            <a:effectRef idx="0">
+              <a:schemeClr val="accent1"/>
+            </a:effectRef>
+            <a:fontRef idx="minor">
+              <a:schemeClr val="lt1"/>
+            </a:fontRef>
+          </p:style>
+          <p:txBody>
+            <a:bodyPr rtlCol="0" anchor="ctr"/>
+            <a:lstStyle/>
+            <a:p>
+              <a:pPr algn="ctr"/>
+              <a:endParaRPr kumimoji="1" lang="ja-JP" altLang="en-US"/>
+            </a:p>
+          </p:txBody>
+        </p:sp>
+        <p:sp>
+          <p:nvSpPr>
+            <p:cNvPr id="15" name="円/楕円 14">
+              <a:extLst>
+                <a:ext uri="{FF2B5EF4-FFF2-40B4-BE49-F238E27FC236}">
+                  <a16:creationId xmlns:a16="http://schemas.microsoft.com/office/drawing/2014/main" id="{ED12059D-DDE8-5469-F226-22BBEA026C32}"/>
+                </a:ext>
+              </a:extLst>
+            </p:cNvPr>
+            <p:cNvSpPr/>
+            <p:nvPr/>
+          </p:nvSpPr>
+          <p:spPr>
+            <a:xfrm>
+              <a:off x="4941008" y="3732670"/>
+              <a:ext cx="97977" cy="97975"/>
+            </a:xfrm>
+            <a:prstGeom prst="ellipse">
+              <a:avLst/>
+            </a:prstGeom>
+            <a:solidFill>
+              <a:srgbClr val="00B0F0"/>
+            </a:solidFill>
+            <a:ln>
+              <a:noFill/>
+            </a:ln>
+          </p:spPr>
+          <p:style>
+            <a:lnRef idx="2">
+              <a:schemeClr val="accent1">
+                <a:shade val="15000"/>
+              </a:schemeClr>
+            </a:lnRef>
+            <a:fillRef idx="1">
+              <a:schemeClr val="accent1"/>
+            </a:fillRef>
+            <a:effectRef idx="0">
+              <a:schemeClr val="accent1"/>
+            </a:effectRef>
+            <a:fontRef idx="minor">
+              <a:schemeClr val="lt1"/>
+            </a:fontRef>
+          </p:style>
+          <p:txBody>
+            <a:bodyPr rtlCol="0" anchor="ctr"/>
+            <a:lstStyle/>
+            <a:p>
+              <a:pPr algn="ctr"/>
+              <a:endParaRPr kumimoji="1" lang="ja-JP" altLang="en-US"/>
+            </a:p>
+          </p:txBody>
+        </p:sp>
+        <p:sp>
+          <p:nvSpPr>
+            <p:cNvPr id="16" name="円/楕円 15">
+              <a:extLst>
+                <a:ext uri="{FF2B5EF4-FFF2-40B4-BE49-F238E27FC236}">
+                  <a16:creationId xmlns:a16="http://schemas.microsoft.com/office/drawing/2014/main" id="{189A7645-EF67-F15A-17AC-55B727B47445}"/>
+                </a:ext>
+              </a:extLst>
+            </p:cNvPr>
+            <p:cNvSpPr/>
+            <p:nvPr/>
+          </p:nvSpPr>
+          <p:spPr>
+            <a:xfrm>
+              <a:off x="6882556" y="2528178"/>
+              <a:ext cx="97977" cy="97975"/>
+            </a:xfrm>
+            <a:prstGeom prst="ellipse">
+              <a:avLst/>
+            </a:prstGeom>
+            <a:solidFill>
+              <a:srgbClr val="00B0F0"/>
+            </a:solidFill>
+            <a:ln>
+              <a:noFill/>
+            </a:ln>
+          </p:spPr>
+          <p:style>
+            <a:lnRef idx="2">
+              <a:schemeClr val="accent1">
+                <a:shade val="15000"/>
+              </a:schemeClr>
+            </a:lnRef>
+            <a:fillRef idx="1">
+              <a:schemeClr val="accent1"/>
+            </a:fillRef>
+            <a:effectRef idx="0">
+              <a:schemeClr val="accent1"/>
+            </a:effectRef>
+            <a:fontRef idx="minor">
+              <a:schemeClr val="lt1"/>
+            </a:fontRef>
+          </p:style>
+          <p:txBody>
+            <a:bodyPr rtlCol="0" anchor="ctr"/>
+            <a:lstStyle/>
+            <a:p>
+              <a:pPr algn="ctr"/>
+              <a:endParaRPr kumimoji="1" lang="ja-JP" altLang="en-US"/>
+            </a:p>
+          </p:txBody>
+        </p:sp>
+        <p:sp>
+          <p:nvSpPr>
+            <p:cNvPr id="17" name="円/楕円 16">
+              <a:extLst>
+                <a:ext uri="{FF2B5EF4-FFF2-40B4-BE49-F238E27FC236}">
+                  <a16:creationId xmlns:a16="http://schemas.microsoft.com/office/drawing/2014/main" id="{540B0FD0-578A-F9DD-4DBC-E2E508B12B58}"/>
+                </a:ext>
+              </a:extLst>
+            </p:cNvPr>
+            <p:cNvSpPr/>
+            <p:nvPr/>
+          </p:nvSpPr>
+          <p:spPr>
+            <a:xfrm>
+              <a:off x="5677761" y="2168850"/>
+              <a:ext cx="97977" cy="97975"/>
+            </a:xfrm>
+            <a:prstGeom prst="ellipse">
+              <a:avLst/>
+            </a:prstGeom>
+            <a:solidFill>
+              <a:srgbClr val="00B0F0"/>
+            </a:solidFill>
+            <a:ln>
+              <a:noFill/>
+            </a:ln>
+          </p:spPr>
+          <p:style>
+            <a:lnRef idx="2">
+              <a:schemeClr val="accent1">
+                <a:shade val="15000"/>
+              </a:schemeClr>
+            </a:lnRef>
+            <a:fillRef idx="1">
+              <a:schemeClr val="accent1"/>
+            </a:fillRef>
+            <a:effectRef idx="0">
+              <a:schemeClr val="accent1"/>
+            </a:effectRef>
+            <a:fontRef idx="minor">
+              <a:schemeClr val="lt1"/>
+            </a:fontRef>
+          </p:style>
+          <p:txBody>
+            <a:bodyPr rtlCol="0" anchor="ctr"/>
+            <a:lstStyle/>
+            <a:p>
+              <a:pPr algn="ctr"/>
+              <a:endParaRPr kumimoji="1" lang="ja-JP" altLang="en-US"/>
+            </a:p>
+          </p:txBody>
+        </p:sp>
+        <p:sp>
+          <p:nvSpPr>
+            <p:cNvPr id="18" name="円/楕円 17">
+              <a:extLst>
+                <a:ext uri="{FF2B5EF4-FFF2-40B4-BE49-F238E27FC236}">
+                  <a16:creationId xmlns:a16="http://schemas.microsoft.com/office/drawing/2014/main" id="{67203840-9064-3D0E-EF1B-BABCED075337}"/>
+                </a:ext>
+              </a:extLst>
+            </p:cNvPr>
+            <p:cNvSpPr/>
+            <p:nvPr/>
+          </p:nvSpPr>
+          <p:spPr>
+            <a:xfrm>
+              <a:off x="5665768" y="2729462"/>
+              <a:ext cx="97977" cy="97975"/>
+            </a:xfrm>
+            <a:prstGeom prst="ellipse">
+              <a:avLst/>
+            </a:prstGeom>
+            <a:solidFill>
+              <a:srgbClr val="00B0F0"/>
+            </a:solidFill>
+            <a:ln>
+              <a:noFill/>
+            </a:ln>
+          </p:spPr>
+          <p:style>
+            <a:lnRef idx="2">
+              <a:schemeClr val="accent1">
+                <a:shade val="15000"/>
+              </a:schemeClr>
+            </a:lnRef>
+            <a:fillRef idx="1">
+              <a:schemeClr val="accent1"/>
+            </a:fillRef>
+            <a:effectRef idx="0">
+              <a:schemeClr val="accent1"/>
+            </a:effectRef>
+            <a:fontRef idx="minor">
+              <a:schemeClr val="lt1"/>
+            </a:fontRef>
+          </p:style>
+          <p:txBody>
+            <a:bodyPr rtlCol="0" anchor="ctr"/>
+            <a:lstStyle/>
+            <a:p>
+              <a:pPr algn="ctr"/>
+              <a:endParaRPr kumimoji="1" lang="ja-JP" altLang="en-US"/>
+            </a:p>
+          </p:txBody>
+        </p:sp>
+        <p:sp>
+          <p:nvSpPr>
+            <p:cNvPr id="19" name="円/楕円 18">
+              <a:extLst>
+                <a:ext uri="{FF2B5EF4-FFF2-40B4-BE49-F238E27FC236}">
+                  <a16:creationId xmlns:a16="http://schemas.microsoft.com/office/drawing/2014/main" id="{47E73E0E-EB56-2F9F-9317-C3132246EBCC}"/>
+                </a:ext>
+              </a:extLst>
+            </p:cNvPr>
+            <p:cNvSpPr/>
+            <p:nvPr/>
+          </p:nvSpPr>
+          <p:spPr>
+            <a:xfrm>
+              <a:off x="6381146" y="2330877"/>
+              <a:ext cx="97977" cy="97975"/>
+            </a:xfrm>
+            <a:prstGeom prst="ellipse">
+              <a:avLst/>
+            </a:prstGeom>
+            <a:solidFill>
+              <a:srgbClr val="00B0F0"/>
+            </a:solidFill>
+            <a:ln>
+              <a:noFill/>
+            </a:ln>
+          </p:spPr>
+          <p:style>
+            <a:lnRef idx="2">
+              <a:schemeClr val="accent1">
+                <a:shade val="15000"/>
+              </a:schemeClr>
+            </a:lnRef>
+            <a:fillRef idx="1">
+              <a:schemeClr val="accent1"/>
+            </a:fillRef>
+            <a:effectRef idx="0">
+              <a:schemeClr val="accent1"/>
+            </a:effectRef>
+            <a:fontRef idx="minor">
+              <a:schemeClr val="lt1"/>
+            </a:fontRef>
+          </p:style>
+          <p:txBody>
+            <a:bodyPr rtlCol="0" anchor="ctr"/>
+            <a:lstStyle/>
+            <a:p>
+              <a:pPr algn="ctr"/>
+              <a:endParaRPr kumimoji="1" lang="ja-JP" altLang="en-US"/>
+            </a:p>
+          </p:txBody>
+        </p:sp>
+        <p:sp>
+          <p:nvSpPr>
+            <p:cNvPr id="20" name="円/楕円 19">
+              <a:extLst>
+                <a:ext uri="{FF2B5EF4-FFF2-40B4-BE49-F238E27FC236}">
+                  <a16:creationId xmlns:a16="http://schemas.microsoft.com/office/drawing/2014/main" id="{18EB38DA-A4A8-A8F8-3110-BC53A3F8BC90}"/>
+                </a:ext>
+              </a:extLst>
+            </p:cNvPr>
+            <p:cNvSpPr/>
+            <p:nvPr/>
+          </p:nvSpPr>
+          <p:spPr>
+            <a:xfrm>
+              <a:off x="6193460" y="1856265"/>
+              <a:ext cx="97977" cy="97975"/>
+            </a:xfrm>
+            <a:prstGeom prst="ellipse">
+              <a:avLst/>
+            </a:prstGeom>
+            <a:solidFill>
+              <a:srgbClr val="00B0F0"/>
+            </a:solidFill>
+            <a:ln>
+              <a:noFill/>
+            </a:ln>
+          </p:spPr>
+          <p:style>
+            <a:lnRef idx="2">
+              <a:schemeClr val="accent1">
+                <a:shade val="15000"/>
+              </a:schemeClr>
+            </a:lnRef>
+            <a:fillRef idx="1">
+              <a:schemeClr val="accent1"/>
+            </a:fillRef>
+            <a:effectRef idx="0">
+              <a:schemeClr val="accent1"/>
+            </a:effectRef>
+            <a:fontRef idx="minor">
+              <a:schemeClr val="lt1"/>
+            </a:fontRef>
+          </p:style>
+          <p:txBody>
+            <a:bodyPr rtlCol="0" anchor="ctr"/>
+            <a:lstStyle/>
+            <a:p>
+              <a:pPr algn="ctr"/>
+              <a:endParaRPr kumimoji="1" lang="ja-JP" altLang="en-US"/>
+            </a:p>
+          </p:txBody>
+        </p:sp>
+        <p:sp>
+          <p:nvSpPr>
+            <p:cNvPr id="21" name="円/楕円 20">
+              <a:extLst>
+                <a:ext uri="{FF2B5EF4-FFF2-40B4-BE49-F238E27FC236}">
+                  <a16:creationId xmlns:a16="http://schemas.microsoft.com/office/drawing/2014/main" id="{D32BAD3D-7886-B0FA-B736-E2AF5A810963}"/>
+                </a:ext>
+              </a:extLst>
+            </p:cNvPr>
+            <p:cNvSpPr/>
+            <p:nvPr/>
+          </p:nvSpPr>
+          <p:spPr>
+            <a:xfrm>
+              <a:off x="6431910" y="2827437"/>
+              <a:ext cx="97977" cy="97975"/>
+            </a:xfrm>
+            <a:prstGeom prst="ellipse">
+              <a:avLst/>
+            </a:prstGeom>
+            <a:solidFill>
+              <a:srgbClr val="00B0F0"/>
+            </a:solidFill>
+            <a:ln>
+              <a:noFill/>
+            </a:ln>
+          </p:spPr>
+          <p:style>
+            <a:lnRef idx="2">
+              <a:schemeClr val="accent1">
+                <a:shade val="15000"/>
+              </a:schemeClr>
+            </a:lnRef>
+            <a:fillRef idx="1">
+              <a:schemeClr val="accent1"/>
+            </a:fillRef>
+            <a:effectRef idx="0">
+              <a:schemeClr val="accent1"/>
+            </a:effectRef>
+            <a:fontRef idx="minor">
+              <a:schemeClr val="lt1"/>
+            </a:fontRef>
+          </p:style>
+          <p:txBody>
+            <a:bodyPr rtlCol="0" anchor="ctr"/>
+            <a:lstStyle/>
+            <a:p>
+              <a:pPr algn="ctr"/>
+              <a:endParaRPr kumimoji="1" lang="ja-JP" altLang="en-US"/>
+            </a:p>
+          </p:txBody>
+        </p:sp>
+        <p:sp>
+          <p:nvSpPr>
+            <p:cNvPr id="22" name="円/楕円 21">
+              <a:extLst>
+                <a:ext uri="{FF2B5EF4-FFF2-40B4-BE49-F238E27FC236}">
+                  <a16:creationId xmlns:a16="http://schemas.microsoft.com/office/drawing/2014/main" id="{28A803A1-0FF3-614B-A4A8-3EF7931F74BA}"/>
+                </a:ext>
+              </a:extLst>
+            </p:cNvPr>
+            <p:cNvSpPr/>
+            <p:nvPr/>
+          </p:nvSpPr>
+          <p:spPr>
+            <a:xfrm>
+              <a:off x="6980533" y="1758290"/>
+              <a:ext cx="97977" cy="97975"/>
+            </a:xfrm>
+            <a:prstGeom prst="ellipse">
+              <a:avLst/>
+            </a:prstGeom>
+            <a:solidFill>
+              <a:srgbClr val="00B0F0"/>
+            </a:solidFill>
+            <a:ln>
+              <a:noFill/>
+            </a:ln>
+          </p:spPr>
+          <p:style>
+            <a:lnRef idx="2">
+              <a:schemeClr val="accent1">
+                <a:shade val="15000"/>
+              </a:schemeClr>
+            </a:lnRef>
+            <a:fillRef idx="1">
+              <a:schemeClr val="accent1"/>
+            </a:fillRef>
+            <a:effectRef idx="0">
+              <a:schemeClr val="accent1"/>
+            </a:effectRef>
+            <a:fontRef idx="minor">
+              <a:schemeClr val="lt1"/>
+            </a:fontRef>
+          </p:style>
+          <p:txBody>
+            <a:bodyPr rtlCol="0" anchor="ctr"/>
+            <a:lstStyle/>
+            <a:p>
+              <a:pPr algn="ctr"/>
+              <a:endParaRPr kumimoji="1" lang="ja-JP" altLang="en-US"/>
+            </a:p>
+          </p:txBody>
+        </p:sp>
+        <p:sp>
+          <p:nvSpPr>
+            <p:cNvPr id="23" name="円/楕円 22">
+              <a:extLst>
+                <a:ext uri="{FF2B5EF4-FFF2-40B4-BE49-F238E27FC236}">
+                  <a16:creationId xmlns:a16="http://schemas.microsoft.com/office/drawing/2014/main" id="{8494CD6E-BDE4-4B04-2565-E61532B9886E}"/>
+                </a:ext>
+              </a:extLst>
+            </p:cNvPr>
+            <p:cNvSpPr/>
+            <p:nvPr/>
+          </p:nvSpPr>
+          <p:spPr>
+            <a:xfrm>
+              <a:off x="3948028" y="4436456"/>
+              <a:ext cx="97977" cy="97975"/>
+            </a:xfrm>
+            <a:prstGeom prst="ellipse">
+              <a:avLst/>
+            </a:prstGeom>
+            <a:solidFill>
+              <a:srgbClr val="00B0F0"/>
+            </a:solidFill>
+            <a:ln>
+              <a:noFill/>
+            </a:ln>
+          </p:spPr>
+          <p:style>
+            <a:lnRef idx="2">
+              <a:schemeClr val="accent1">
+                <a:shade val="15000"/>
+              </a:schemeClr>
+            </a:lnRef>
+            <a:fillRef idx="1">
+              <a:schemeClr val="accent1"/>
+            </a:fillRef>
+            <a:effectRef idx="0">
+              <a:schemeClr val="accent1"/>
+            </a:effectRef>
+            <a:fontRef idx="minor">
+              <a:schemeClr val="lt1"/>
+            </a:fontRef>
+          </p:style>
+          <p:txBody>
+            <a:bodyPr rtlCol="0" anchor="ctr"/>
+            <a:lstStyle/>
+            <a:p>
+              <a:pPr algn="ctr"/>
+              <a:endParaRPr kumimoji="1" lang="ja-JP" altLang="en-US"/>
+            </a:p>
+          </p:txBody>
+        </p:sp>
+        <p:sp>
+          <p:nvSpPr>
+            <p:cNvPr id="24" name="円/楕円 23">
+              <a:extLst>
+                <a:ext uri="{FF2B5EF4-FFF2-40B4-BE49-F238E27FC236}">
+                  <a16:creationId xmlns:a16="http://schemas.microsoft.com/office/drawing/2014/main" id="{D6BC5B06-46BC-46D8-F50A-8FA7EAC8BA68}"/>
+                </a:ext>
+              </a:extLst>
+            </p:cNvPr>
+            <p:cNvSpPr/>
+            <p:nvPr/>
+          </p:nvSpPr>
+          <p:spPr>
+            <a:xfrm>
+              <a:off x="4708499" y="4150072"/>
+              <a:ext cx="97977" cy="97975"/>
+            </a:xfrm>
+            <a:prstGeom prst="ellipse">
+              <a:avLst/>
+            </a:prstGeom>
+            <a:solidFill>
+              <a:srgbClr val="00B0F0"/>
+            </a:solidFill>
+            <a:ln>
+              <a:noFill/>
+            </a:ln>
+          </p:spPr>
+          <p:style>
+            <a:lnRef idx="2">
+              <a:schemeClr val="accent1">
+                <a:shade val="15000"/>
+              </a:schemeClr>
+            </a:lnRef>
+            <a:fillRef idx="1">
+              <a:schemeClr val="accent1"/>
+            </a:fillRef>
+            <a:effectRef idx="0">
+              <a:schemeClr val="accent1"/>
+            </a:effectRef>
+            <a:fontRef idx="minor">
+              <a:schemeClr val="lt1"/>
+            </a:fontRef>
+          </p:style>
+          <p:txBody>
+            <a:bodyPr rtlCol="0" anchor="ctr"/>
+            <a:lstStyle/>
+            <a:p>
+              <a:pPr algn="ctr"/>
+              <a:endParaRPr kumimoji="1" lang="ja-JP" altLang="en-US"/>
+            </a:p>
+          </p:txBody>
+        </p:sp>
+        <p:sp>
+          <p:nvSpPr>
+            <p:cNvPr id="25" name="円/楕円 24">
+              <a:extLst>
+                <a:ext uri="{FF2B5EF4-FFF2-40B4-BE49-F238E27FC236}">
+                  <a16:creationId xmlns:a16="http://schemas.microsoft.com/office/drawing/2014/main" id="{0226BC2A-4DC8-0C0B-9E2A-E918FAB66278}"/>
+                </a:ext>
+              </a:extLst>
+            </p:cNvPr>
+            <p:cNvSpPr/>
+            <p:nvPr/>
+          </p:nvSpPr>
+          <p:spPr>
+            <a:xfrm>
+              <a:off x="4065412" y="3524165"/>
+              <a:ext cx="97977" cy="97975"/>
+            </a:xfrm>
+            <a:prstGeom prst="ellipse">
+              <a:avLst/>
+            </a:prstGeom>
+            <a:solidFill>
+              <a:srgbClr val="00B0F0"/>
+            </a:solidFill>
+            <a:ln>
+              <a:noFill/>
+            </a:ln>
+          </p:spPr>
+          <p:style>
+            <a:lnRef idx="2">
+              <a:schemeClr val="accent1">
+                <a:shade val="15000"/>
+              </a:schemeClr>
+            </a:lnRef>
+            <a:fillRef idx="1">
+              <a:schemeClr val="accent1"/>
+            </a:fillRef>
+            <a:effectRef idx="0">
+              <a:schemeClr val="accent1"/>
+            </a:effectRef>
+            <a:fontRef idx="minor">
+              <a:schemeClr val="lt1"/>
+            </a:fontRef>
+          </p:style>
+          <p:txBody>
+            <a:bodyPr rtlCol="0" anchor="ctr"/>
+            <a:lstStyle/>
+            <a:p>
+              <a:pPr algn="ctr"/>
+              <a:endParaRPr kumimoji="1" lang="ja-JP" altLang="en-US"/>
+            </a:p>
+          </p:txBody>
+        </p:sp>
+        <p:sp>
+          <p:nvSpPr>
+            <p:cNvPr id="26" name="円/楕円 25">
+              <a:extLst>
+                <a:ext uri="{FF2B5EF4-FFF2-40B4-BE49-F238E27FC236}">
+                  <a16:creationId xmlns:a16="http://schemas.microsoft.com/office/drawing/2014/main" id="{BE20CA88-82BF-3F8A-F306-37DA44DE1297}"/>
+                </a:ext>
+              </a:extLst>
+            </p:cNvPr>
+            <p:cNvSpPr/>
+            <p:nvPr/>
+          </p:nvSpPr>
+          <p:spPr>
+            <a:xfrm>
+              <a:off x="4116176" y="4020725"/>
+              <a:ext cx="97977" cy="97975"/>
+            </a:xfrm>
+            <a:prstGeom prst="ellipse">
+              <a:avLst/>
+            </a:prstGeom>
+            <a:solidFill>
+              <a:srgbClr val="00B0F0"/>
+            </a:solidFill>
+            <a:ln>
+              <a:noFill/>
+            </a:ln>
+          </p:spPr>
+          <p:style>
+            <a:lnRef idx="2">
+              <a:schemeClr val="accent1">
+                <a:shade val="15000"/>
+              </a:schemeClr>
+            </a:lnRef>
+            <a:fillRef idx="1">
+              <a:schemeClr val="accent1"/>
+            </a:fillRef>
+            <a:effectRef idx="0">
+              <a:schemeClr val="accent1"/>
+            </a:effectRef>
+            <a:fontRef idx="minor">
+              <a:schemeClr val="lt1"/>
+            </a:fontRef>
+          </p:style>
+          <p:txBody>
+            <a:bodyPr rtlCol="0" anchor="ctr"/>
+            <a:lstStyle/>
+            <a:p>
+              <a:pPr algn="ctr"/>
+              <a:endParaRPr kumimoji="1" lang="ja-JP" altLang="en-US"/>
+            </a:p>
+          </p:txBody>
+        </p:sp>
+        <p:sp>
+          <p:nvSpPr>
+            <p:cNvPr id="27" name="円/楕円 26">
+              <a:extLst>
+                <a:ext uri="{FF2B5EF4-FFF2-40B4-BE49-F238E27FC236}">
+                  <a16:creationId xmlns:a16="http://schemas.microsoft.com/office/drawing/2014/main" id="{EBF87DE0-E949-2A47-C814-9B2FE0424481}"/>
+                </a:ext>
+              </a:extLst>
+            </p:cNvPr>
+            <p:cNvSpPr/>
+            <p:nvPr/>
+          </p:nvSpPr>
+          <p:spPr>
+            <a:xfrm>
+              <a:off x="5283384" y="3194180"/>
+              <a:ext cx="97977" cy="97975"/>
+            </a:xfrm>
+            <a:prstGeom prst="ellipse">
+              <a:avLst/>
+            </a:prstGeom>
+            <a:solidFill>
+              <a:srgbClr val="00B0F0"/>
+            </a:solidFill>
+            <a:ln>
+              <a:noFill/>
+            </a:ln>
+          </p:spPr>
+          <p:style>
+            <a:lnRef idx="2">
+              <a:schemeClr val="accent1">
+                <a:shade val="15000"/>
+              </a:schemeClr>
+            </a:lnRef>
+            <a:fillRef idx="1">
+              <a:schemeClr val="accent1"/>
+            </a:fillRef>
+            <a:effectRef idx="0">
+              <a:schemeClr val="accent1"/>
+            </a:effectRef>
+            <a:fontRef idx="minor">
+              <a:schemeClr val="lt1"/>
+            </a:fontRef>
+          </p:style>
+          <p:txBody>
+            <a:bodyPr rtlCol="0" anchor="ctr"/>
+            <a:lstStyle/>
+            <a:p>
+              <a:pPr algn="ctr"/>
+              <a:endParaRPr kumimoji="1" lang="ja-JP" altLang="en-US"/>
+            </a:p>
+          </p:txBody>
+        </p:sp>
+        <p:sp>
+          <p:nvSpPr>
+            <p:cNvPr id="28" name="円/楕円 27">
+              <a:extLst>
+                <a:ext uri="{FF2B5EF4-FFF2-40B4-BE49-F238E27FC236}">
+                  <a16:creationId xmlns:a16="http://schemas.microsoft.com/office/drawing/2014/main" id="{F8320DA0-A992-E062-76A0-24FF68AAEA1C}"/>
+                </a:ext>
+              </a:extLst>
+            </p:cNvPr>
+            <p:cNvSpPr/>
+            <p:nvPr/>
+          </p:nvSpPr>
+          <p:spPr>
+            <a:xfrm>
+              <a:off x="4452812" y="3498981"/>
+              <a:ext cx="97977" cy="97975"/>
+            </a:xfrm>
+            <a:prstGeom prst="ellipse">
+              <a:avLst/>
+            </a:prstGeom>
+            <a:solidFill>
+              <a:srgbClr val="00B0F0"/>
+            </a:solidFill>
+            <a:ln>
+              <a:noFill/>
+            </a:ln>
+          </p:spPr>
+          <p:style>
+            <a:lnRef idx="2">
+              <a:schemeClr val="accent1">
+                <a:shade val="15000"/>
+              </a:schemeClr>
+            </a:lnRef>
+            <a:fillRef idx="1">
+              <a:schemeClr val="accent1"/>
+            </a:fillRef>
+            <a:effectRef idx="0">
+              <a:schemeClr val="accent1"/>
+            </a:effectRef>
+            <a:fontRef idx="minor">
+              <a:schemeClr val="lt1"/>
+            </a:fontRef>
+          </p:style>
+          <p:txBody>
+            <a:bodyPr rtlCol="0" anchor="ctr"/>
+            <a:lstStyle/>
+            <a:p>
+              <a:pPr algn="ctr"/>
+              <a:endParaRPr kumimoji="1" lang="ja-JP" altLang="en-US"/>
+            </a:p>
+          </p:txBody>
+        </p:sp>
+        <p:sp>
+          <p:nvSpPr>
+            <p:cNvPr id="29" name="円/楕円 28">
+              <a:extLst>
+                <a:ext uri="{FF2B5EF4-FFF2-40B4-BE49-F238E27FC236}">
+                  <a16:creationId xmlns:a16="http://schemas.microsoft.com/office/drawing/2014/main" id="{762CC2FD-1376-C922-07C1-D6CC6C65E0F6}"/>
+                </a:ext>
+              </a:extLst>
+            </p:cNvPr>
+            <p:cNvSpPr/>
+            <p:nvPr/>
+          </p:nvSpPr>
+          <p:spPr>
+            <a:xfrm>
+              <a:off x="5511572" y="3907193"/>
+              <a:ext cx="97977" cy="97975"/>
+            </a:xfrm>
+            <a:prstGeom prst="ellipse">
+              <a:avLst/>
+            </a:prstGeom>
+            <a:solidFill>
+              <a:srgbClr val="00B0F0"/>
+            </a:solidFill>
+            <a:ln>
+              <a:noFill/>
+            </a:ln>
+          </p:spPr>
+          <p:style>
+            <a:lnRef idx="2">
+              <a:schemeClr val="accent1">
+                <a:shade val="15000"/>
+              </a:schemeClr>
+            </a:lnRef>
+            <a:fillRef idx="1">
+              <a:schemeClr val="accent1"/>
+            </a:fillRef>
+            <a:effectRef idx="0">
+              <a:schemeClr val="accent1"/>
+            </a:effectRef>
+            <a:fontRef idx="minor">
+              <a:schemeClr val="lt1"/>
+            </a:fontRef>
+          </p:style>
+          <p:txBody>
+            <a:bodyPr rtlCol="0" anchor="ctr"/>
+            <a:lstStyle/>
+            <a:p>
+              <a:pPr algn="ctr"/>
+              <a:endParaRPr kumimoji="1" lang="ja-JP" altLang="en-US"/>
+            </a:p>
+          </p:txBody>
+        </p:sp>
+        <p:sp>
+          <p:nvSpPr>
+            <p:cNvPr id="30" name="円/楕円 29">
+              <a:extLst>
+                <a:ext uri="{FF2B5EF4-FFF2-40B4-BE49-F238E27FC236}">
+                  <a16:creationId xmlns:a16="http://schemas.microsoft.com/office/drawing/2014/main" id="{D8C5F480-4774-FB94-A53B-1B8806E2122D}"/>
+                </a:ext>
+              </a:extLst>
+            </p:cNvPr>
+            <p:cNvSpPr/>
+            <p:nvPr/>
+          </p:nvSpPr>
+          <p:spPr>
+            <a:xfrm>
+              <a:off x="5234396" y="3907193"/>
+              <a:ext cx="97977" cy="97975"/>
+            </a:xfrm>
+            <a:prstGeom prst="ellipse">
+              <a:avLst/>
+            </a:prstGeom>
+            <a:solidFill>
+              <a:srgbClr val="00B0F0"/>
+            </a:solidFill>
+            <a:ln>
+              <a:noFill/>
+            </a:ln>
+          </p:spPr>
+          <p:style>
+            <a:lnRef idx="2">
+              <a:schemeClr val="accent1">
+                <a:shade val="15000"/>
+              </a:schemeClr>
+            </a:lnRef>
+            <a:fillRef idx="1">
+              <a:schemeClr val="accent1"/>
+            </a:fillRef>
+            <a:effectRef idx="0">
+              <a:schemeClr val="accent1"/>
+            </a:effectRef>
+            <a:fontRef idx="minor">
+              <a:schemeClr val="lt1"/>
+            </a:fontRef>
+          </p:style>
+          <p:txBody>
+            <a:bodyPr rtlCol="0" anchor="ctr"/>
+            <a:lstStyle/>
+            <a:p>
+              <a:pPr algn="ctr"/>
+              <a:endParaRPr kumimoji="1" lang="ja-JP" altLang="en-US"/>
+            </a:p>
+          </p:txBody>
+        </p:sp>
+        <p:sp>
+          <p:nvSpPr>
+            <p:cNvPr id="34" name="テキスト ボックス 33">
+              <a:extLst>
+                <a:ext uri="{FF2B5EF4-FFF2-40B4-BE49-F238E27FC236}">
+                  <a16:creationId xmlns:a16="http://schemas.microsoft.com/office/drawing/2014/main" id="{D0B250FF-CC35-2A01-9A26-4EA64867D830}"/>
+                </a:ext>
+              </a:extLst>
+            </p:cNvPr>
+            <p:cNvSpPr txBox="1"/>
+            <p:nvPr/>
+          </p:nvSpPr>
+          <p:spPr>
+            <a:xfrm>
+              <a:off x="7922702" y="5422240"/>
+              <a:ext cx="1278081" cy="369332"/>
+            </a:xfrm>
+            <a:prstGeom prst="rect">
+              <a:avLst/>
+            </a:prstGeom>
+            <a:noFill/>
+          </p:spPr>
+          <p:txBody>
+            <a:bodyPr wrap="square" rtlCol="0">
+              <a:spAutoFit/>
+            </a:bodyPr>
+            <a:lstStyle/>
+            <a:p>
+              <a:r>
+                <a:rPr lang="ja-JP" altLang="en-US">
+                  <a:latin typeface="HGPSoeiKakugothicUB" panose="020B0900000000000000" pitchFamily="34" charset="-128"/>
+                  <a:ea typeface="HGPSoeiKakugothicUB" panose="020B0900000000000000" pitchFamily="34" charset="-128"/>
+                </a:rPr>
+                <a:t>身長</a:t>
+              </a:r>
+              <a:r>
+                <a:rPr lang="en-US" altLang="ja-JP" dirty="0">
+                  <a:latin typeface="HGPSoeiKakugothicUB" panose="020B0900000000000000" pitchFamily="34" charset="-128"/>
+                  <a:ea typeface="HGPSoeiKakugothicUB" panose="020B0900000000000000" pitchFamily="34" charset="-128"/>
+                </a:rPr>
+                <a:t> (cm)</a:t>
+              </a:r>
+              <a:endParaRPr kumimoji="1" lang="ja-JP" altLang="en-US">
+                <a:latin typeface="HGPSoeiKakugothicUB" panose="020B0900000000000000" pitchFamily="34" charset="-128"/>
+                <a:ea typeface="HGPSoeiKakugothicUB" panose="020B0900000000000000" pitchFamily="34" charset="-128"/>
+              </a:endParaRPr>
+            </a:p>
+          </p:txBody>
+        </p:sp>
+        <p:sp>
+          <p:nvSpPr>
+            <p:cNvPr id="35" name="テキスト ボックス 34">
+              <a:extLst>
+                <a:ext uri="{FF2B5EF4-FFF2-40B4-BE49-F238E27FC236}">
+                  <a16:creationId xmlns:a16="http://schemas.microsoft.com/office/drawing/2014/main" id="{C44AC40D-7E43-FDE7-3861-7B3F33FC6721}"/>
+                </a:ext>
+              </a:extLst>
+            </p:cNvPr>
+            <p:cNvSpPr txBox="1"/>
+            <p:nvPr/>
+          </p:nvSpPr>
+          <p:spPr>
+            <a:xfrm rot="16200000">
+              <a:off x="1451352" y="1056341"/>
+              <a:ext cx="1278081" cy="369332"/>
+            </a:xfrm>
+            <a:prstGeom prst="rect">
+              <a:avLst/>
+            </a:prstGeom>
+            <a:noFill/>
+          </p:spPr>
+          <p:txBody>
+            <a:bodyPr wrap="square" rtlCol="0">
+              <a:spAutoFit/>
+            </a:bodyPr>
+            <a:lstStyle/>
+            <a:p>
+              <a:r>
+                <a:rPr lang="ja-JP" altLang="en-US">
+                  <a:latin typeface="HGPSoeiKakugothicUB" panose="020B0900000000000000" pitchFamily="34" charset="-128"/>
+                  <a:ea typeface="HGPSoeiKakugothicUB" panose="020B0900000000000000" pitchFamily="34" charset="-128"/>
+                </a:rPr>
+                <a:t>体重</a:t>
+              </a:r>
+              <a:r>
+                <a:rPr lang="en-US" altLang="ja-JP" dirty="0">
+                  <a:latin typeface="HGPSoeiKakugothicUB" panose="020B0900000000000000" pitchFamily="34" charset="-128"/>
+                  <a:ea typeface="HGPSoeiKakugothicUB" panose="020B0900000000000000" pitchFamily="34" charset="-128"/>
+                </a:rPr>
+                <a:t> (kg)</a:t>
+              </a:r>
+              <a:endParaRPr kumimoji="1" lang="ja-JP" altLang="en-US">
+                <a:latin typeface="HGPSoeiKakugothicUB" panose="020B0900000000000000" pitchFamily="34" charset="-128"/>
+                <a:ea typeface="HGPSoeiKakugothicUB" panose="020B0900000000000000" pitchFamily="34" charset="-128"/>
+              </a:endParaRPr>
+            </a:p>
+          </p:txBody>
+        </p:sp>
+        <mc:AlternateContent xmlns:mc="http://schemas.openxmlformats.org/markup-compatibility/2006">
+          <mc:Choice xmlns:a14="http://schemas.microsoft.com/office/drawing/2010/main" Requires="a14">
+            <p:sp>
+              <p:nvSpPr>
+                <p:cNvPr id="36" name="テキスト ボックス 35">
+                  <a:extLst>
+                    <a:ext uri="{FF2B5EF4-FFF2-40B4-BE49-F238E27FC236}">
+                      <a16:creationId xmlns:a16="http://schemas.microsoft.com/office/drawing/2014/main" id="{CEF57B98-5852-6231-140A-6785E31C8878}"/>
+                    </a:ext>
+                  </a:extLst>
+                </p:cNvPr>
+                <p:cNvSpPr txBox="1"/>
+                <p:nvPr/>
+              </p:nvSpPr>
+              <p:spPr>
+                <a:xfrm>
+                  <a:off x="7476621" y="1941587"/>
+                  <a:ext cx="1848968" cy="430887"/>
+                </a:xfrm>
+                <a:prstGeom prst="rect">
+                  <a:avLst/>
+                </a:prstGeom>
+                <a:noFill/>
+              </p:spPr>
+              <p:txBody>
+                <a:bodyPr wrap="none" lIns="0" tIns="0" rIns="0" bIns="0" rtlCol="0">
+                  <a:spAutoFit/>
+                </a:bodyPr>
+                <a:lstStyle/>
+                <a:p>
+                  <a14:m>
+                    <m:oMathPara xmlns:m="http://schemas.openxmlformats.org/officeDocument/2006/math">
+                      <m:oMathParaPr>
+                        <m:jc m:val="centerGroup"/>
+                      </m:oMathParaPr>
+                      <m:oMath xmlns:m="http://schemas.openxmlformats.org/officeDocument/2006/math">
+                        <m:r>
+                          <a:rPr kumimoji="1" lang="en-US" altLang="ja-JP" sz="2800" b="0" i="1" smtClean="0">
+                            <a:latin typeface="Cambria Math" panose="02040503050406030204" pitchFamily="18" charset="0"/>
+                          </a:rPr>
+                          <m:t>𝑦</m:t>
+                        </m:r>
+                        <m:r>
+                          <a:rPr kumimoji="1" lang="en-US" altLang="ja-JP" sz="2800" b="0" i="1" smtClean="0">
+                            <a:latin typeface="Cambria Math" panose="02040503050406030204" pitchFamily="18" charset="0"/>
+                          </a:rPr>
+                          <m:t>=</m:t>
+                        </m:r>
+                        <m:r>
+                          <a:rPr kumimoji="1" lang="en-US" altLang="ja-JP" sz="2800" b="0" i="1" smtClean="0">
+                            <a:latin typeface="Cambria Math" panose="02040503050406030204" pitchFamily="18" charset="0"/>
+                          </a:rPr>
+                          <m:t>𝛼</m:t>
+                        </m:r>
+                        <m:r>
+                          <a:rPr kumimoji="1" lang="en-US" altLang="ja-JP" sz="2800" b="0" i="1" smtClean="0">
+                            <a:latin typeface="Cambria Math" panose="02040503050406030204" pitchFamily="18" charset="0"/>
+                          </a:rPr>
+                          <m:t>+</m:t>
+                        </m:r>
+                        <m:r>
+                          <a:rPr kumimoji="1" lang="en-US" altLang="ja-JP" sz="2800" b="0" i="1" smtClean="0">
+                            <a:latin typeface="Cambria Math" panose="02040503050406030204" pitchFamily="18" charset="0"/>
+                          </a:rPr>
+                          <m:t>𝛽</m:t>
+                        </m:r>
+                        <m:r>
+                          <a:rPr kumimoji="1" lang="en-US" altLang="ja-JP" sz="2800" b="0" i="1" smtClean="0">
+                            <a:latin typeface="Cambria Math" panose="02040503050406030204" pitchFamily="18" charset="0"/>
+                          </a:rPr>
+                          <m:t>𝑥</m:t>
+                        </m:r>
+                      </m:oMath>
+                    </m:oMathPara>
+                  </a14:m>
+                  <a:endParaRPr kumimoji="1" lang="ja-JP" altLang="en-US" sz="2800"/>
+                </a:p>
+              </p:txBody>
+            </p:sp>
+          </mc:Choice>
+          <mc:Fallback>
+            <p:sp>
+              <p:nvSpPr>
+                <p:cNvPr id="36" name="テキスト ボックス 35">
+                  <a:extLst>
+                    <a:ext uri="{FF2B5EF4-FFF2-40B4-BE49-F238E27FC236}">
+                      <a16:creationId xmlns:a16="http://schemas.microsoft.com/office/drawing/2014/main" id="{CEF57B98-5852-6231-140A-6785E31C8878}"/>
+                    </a:ext>
+                  </a:extLst>
+                </p:cNvPr>
+                <p:cNvSpPr txBox="1">
+                  <a:spLocks noRot="1" noChangeAspect="1" noMove="1" noResize="1" noEditPoints="1" noAdjustHandles="1" noChangeArrowheads="1" noChangeShapeType="1" noTextEdit="1"/>
+                </p:cNvSpPr>
+                <p:nvPr/>
+              </p:nvSpPr>
+              <p:spPr>
+                <a:xfrm>
+                  <a:off x="7476621" y="1941587"/>
+                  <a:ext cx="1848968" cy="430887"/>
+                </a:xfrm>
+                <a:prstGeom prst="rect">
+                  <a:avLst/>
+                </a:prstGeom>
+                <a:blipFill>
+                  <a:blip r:embed="rId2"/>
+                  <a:stretch>
+                    <a:fillRect l="-3401" t="-2941" r="-5442" b="-35294"/>
+                  </a:stretch>
+                </a:blipFill>
+              </p:spPr>
+              <p:txBody>
+                <a:bodyPr/>
+                <a:lstStyle/>
+                <a:p>
+                  <a:r>
+                    <a:rPr lang="ja-JP" altLang="en-US">
+                      <a:noFill/>
+                    </a:rPr>
+                    <a:t> </a:t>
+                  </a:r>
+                </a:p>
+              </p:txBody>
+            </p:sp>
+          </mc:Fallback>
+        </mc:AlternateContent>
+        <p:cxnSp>
+          <p:nvCxnSpPr>
+            <p:cNvPr id="38" name="曲線コネクタ 37">
+              <a:extLst>
+                <a:ext uri="{FF2B5EF4-FFF2-40B4-BE49-F238E27FC236}">
+                  <a16:creationId xmlns:a16="http://schemas.microsoft.com/office/drawing/2014/main" id="{0922B44E-C9EF-90CF-20FA-9BB0472B6FA2}"/>
+                </a:ext>
+              </a:extLst>
+            </p:cNvPr>
+            <p:cNvCxnSpPr>
+              <a:cxnSpLocks/>
+              <a:stCxn id="36" idx="2"/>
+            </p:cNvCxnSpPr>
+            <p:nvPr/>
+          </p:nvCxnSpPr>
+          <p:spPr>
+            <a:xfrm rot="5400000" flipH="1">
+              <a:off x="7492539" y="1463909"/>
+              <a:ext cx="41595" cy="1775536"/>
+            </a:xfrm>
+            <a:prstGeom prst="curvedConnector4">
+              <a:avLst>
+                <a:gd name="adj1" fmla="val -549585"/>
+                <a:gd name="adj2" fmla="val 76034"/>
+              </a:avLst>
+            </a:prstGeom>
+            <a:ln w="38100">
+              <a:solidFill>
+                <a:srgbClr val="FF0000"/>
+              </a:solidFill>
+              <a:tailEnd type="triangle"/>
+            </a:ln>
+          </p:spPr>
+          <p:style>
+            <a:lnRef idx="2">
+              <a:schemeClr val="accent1"/>
+            </a:lnRef>
+            <a:fillRef idx="0">
+              <a:schemeClr val="accent1"/>
+            </a:fillRef>
+            <a:effectRef idx="1">
+              <a:schemeClr val="accent1"/>
+            </a:effectRef>
+            <a:fontRef idx="minor">
+              <a:schemeClr val="tx1"/>
+            </a:fontRef>
+          </p:style>
+        </p:cxnSp>
+      </p:grpSp>
+    </p:spTree>
+    <p:extLst>
+      <p:ext uri="{BB962C8B-B14F-4D97-AF65-F5344CB8AC3E}">
+        <p14:creationId xmlns:p14="http://schemas.microsoft.com/office/powerpoint/2010/main" val="3970249307"/>
+      </p:ext>
+    </p:extLst>
+  </p:cSld>
+  <p:clrMapOvr>
+    <a:masterClrMapping/>
+  </p:clrMapOvr>
+</p:sld>
+</file>
+
 <file path=ppt/theme/theme1.xml><?xml version="1.0" encoding="utf-8"?>
 <a:theme xmlns:a="http://schemas.openxmlformats.org/drawingml/2006/main" name="Office テーマ">
   <a:themeElements>

</xml_diff>